<commit_message>
Fix: Order details back button text visibility and update login success message
</commit_message>
<xml_diff>
--- a/FYPCS-G02.pptx
+++ b/FYPCS-G02.pptx
@@ -40,11 +40,11 @@
       <p:bold r:id="rId25"/>
     </p:embeddedFont>
     <p:embeddedFont>
-      <p:font typeface="Times New Roman MT" panose="020B0604020202020204" charset="0"/>
+      <p:font typeface="Canva Sans" panose="020B0604020202020204" charset="0"/>
       <p:regular r:id="rId26"/>
     </p:embeddedFont>
     <p:embeddedFont>
-      <p:font typeface="Canva Sans" panose="020B0604020202020204" charset="0"/>
+      <p:font typeface="Times New Roman MT" panose="020B0604020202020204" charset="0"/>
       <p:regular r:id="rId27"/>
     </p:embeddedFont>
     <p:embeddedFont>
@@ -351,7 +351,7 @@
             <a:fld id="{1D8BD707-D9CF-40AE-B4C6-C98DA3205C09}" type="datetimeFigureOut">
               <a:rPr lang="en-US" smtClean="0"/>
               <a:pPr/>
-              <a:t>7/13/2026</a:t>
+              <a:t>7/16/2026</a:t>
             </a:fld>
             <a:endParaRPr lang="en-US"/>
           </a:p>
@@ -518,7 +518,7 @@
             <a:fld id="{1D8BD707-D9CF-40AE-B4C6-C98DA3205C09}" type="datetimeFigureOut">
               <a:rPr lang="en-US" smtClean="0"/>
               <a:pPr/>
-              <a:t>7/13/2026</a:t>
+              <a:t>7/16/2026</a:t>
             </a:fld>
             <a:endParaRPr lang="en-US"/>
           </a:p>
@@ -695,7 +695,7 @@
             <a:fld id="{1D8BD707-D9CF-40AE-B4C6-C98DA3205C09}" type="datetimeFigureOut">
               <a:rPr lang="en-US" smtClean="0"/>
               <a:pPr/>
-              <a:t>7/13/2026</a:t>
+              <a:t>7/16/2026</a:t>
             </a:fld>
             <a:endParaRPr lang="en-US"/>
           </a:p>
@@ -862,7 +862,7 @@
             <a:fld id="{1D8BD707-D9CF-40AE-B4C6-C98DA3205C09}" type="datetimeFigureOut">
               <a:rPr lang="en-US" smtClean="0"/>
               <a:pPr/>
-              <a:t>7/13/2026</a:t>
+              <a:t>7/16/2026</a:t>
             </a:fld>
             <a:endParaRPr lang="en-US"/>
           </a:p>
@@ -1105,7 +1105,7 @@
             <a:fld id="{1D8BD707-D9CF-40AE-B4C6-C98DA3205C09}" type="datetimeFigureOut">
               <a:rPr lang="en-US" smtClean="0"/>
               <a:pPr/>
-              <a:t>7/13/2026</a:t>
+              <a:t>7/16/2026</a:t>
             </a:fld>
             <a:endParaRPr lang="en-US"/>
           </a:p>
@@ -1390,7 +1390,7 @@
             <a:fld id="{1D8BD707-D9CF-40AE-B4C6-C98DA3205C09}" type="datetimeFigureOut">
               <a:rPr lang="en-US" smtClean="0"/>
               <a:pPr/>
-              <a:t>7/13/2026</a:t>
+              <a:t>7/16/2026</a:t>
             </a:fld>
             <a:endParaRPr lang="en-US"/>
           </a:p>
@@ -1809,7 +1809,7 @@
             <a:fld id="{1D8BD707-D9CF-40AE-B4C6-C98DA3205C09}" type="datetimeFigureOut">
               <a:rPr lang="en-US" smtClean="0"/>
               <a:pPr/>
-              <a:t>7/13/2026</a:t>
+              <a:t>7/16/2026</a:t>
             </a:fld>
             <a:endParaRPr lang="en-US"/>
           </a:p>
@@ -1924,7 +1924,7 @@
             <a:fld id="{1D8BD707-D9CF-40AE-B4C6-C98DA3205C09}" type="datetimeFigureOut">
               <a:rPr lang="en-US" smtClean="0"/>
               <a:pPr/>
-              <a:t>7/13/2026</a:t>
+              <a:t>7/16/2026</a:t>
             </a:fld>
             <a:endParaRPr lang="en-US"/>
           </a:p>
@@ -2016,7 +2016,7 @@
             <a:fld id="{1D8BD707-D9CF-40AE-B4C6-C98DA3205C09}" type="datetimeFigureOut">
               <a:rPr lang="en-US" smtClean="0"/>
               <a:pPr/>
-              <a:t>7/13/2026</a:t>
+              <a:t>7/16/2026</a:t>
             </a:fld>
             <a:endParaRPr lang="en-US"/>
           </a:p>
@@ -2290,7 +2290,7 @@
             <a:fld id="{1D8BD707-D9CF-40AE-B4C6-C98DA3205C09}" type="datetimeFigureOut">
               <a:rPr lang="en-US" smtClean="0"/>
               <a:pPr/>
-              <a:t>7/13/2026</a:t>
+              <a:t>7/16/2026</a:t>
             </a:fld>
             <a:endParaRPr lang="en-US"/>
           </a:p>
@@ -2540,7 +2540,7 @@
             <a:fld id="{1D8BD707-D9CF-40AE-B4C6-C98DA3205C09}" type="datetimeFigureOut">
               <a:rPr lang="en-US" smtClean="0"/>
               <a:pPr/>
-              <a:t>7/13/2026</a:t>
+              <a:t>7/16/2026</a:t>
             </a:fld>
             <a:endParaRPr lang="en-US"/>
           </a:p>
@@ -2750,7 +2750,7 @@
             <a:fld id="{1D8BD707-D9CF-40AE-B4C6-C98DA3205C09}" type="datetimeFigureOut">
               <a:rPr lang="en-US" smtClean="0"/>
               <a:pPr/>
-              <a:t>7/13/2026</a:t>
+              <a:t>7/16/2026</a:t>
             </a:fld>
             <a:endParaRPr lang="en-US"/>
           </a:p>
@@ -3176,7 +3176,7 @@
         <p:spPr>
           <a:xfrm>
             <a:off x="762001" y="2443130"/>
-            <a:ext cx="18037430" cy="1565365"/>
+            <a:ext cx="18037430" cy="1846659"/>
           </a:xfrm>
           <a:prstGeom prst="rect">
             <a:avLst/>
@@ -3215,7 +3215,7 @@
                 <a:cs typeface="Times New Roman Bold"/>
                 <a:sym typeface="Times New Roman Bold"/>
               </a:rPr>
-              <a:t>AI Based E-commerce Platform (StitchSmart)</a:t>
+              <a:t>AI ASSISTANT ECOMMERCE STORE (StitchSmart)</a:t>
             </a:r>
             <a:endParaRPr lang="en-US" sz="5400" b="1" dirty="0">
               <a:solidFill>
@@ -3731,7 +3731,7 @@
           <p:nvPr>
             <p:extLst>
               <p:ext uri="{D42A27DB-BD31-4B8C-83A1-F6EECF244321}">
-                <p14:modId xmlns:p14="http://schemas.microsoft.com/office/powerpoint/2010/main" val="1395583245"/>
+                <p14:modId xmlns:p14="http://schemas.microsoft.com/office/powerpoint/2010/main" val="4032759639"/>
               </p:ext>
             </p:extLst>
           </p:nvPr>
@@ -3744,7 +3744,7 @@
           <a:graphicData uri="http://schemas.openxmlformats.org/drawingml/2006/table">
             <a:tbl>
               <a:tblPr firstRow="1" bandRow="1">
-                <a:tableStyleId>{5C22544A-7EE6-4342-B048-85BDC9FD1C3A}</a:tableStyleId>
+                <a:tableStyleId>{2D5ABB26-0587-4C30-8999-92F81FD0307C}</a:tableStyleId>
               </a:tblPr>
               <a:tblGrid>
                 <a:gridCol w="6096000"/>
@@ -3758,14 +3758,20 @@
                     <a:p>
                       <a:pPr algn="ctr"/>
                       <a:r>
-                        <a:rPr lang="en-US" sz="2800" dirty="0" smtClean="0">
+                        <a:rPr lang="en-US" sz="3200" b="1" dirty="0" smtClean="0">
+                          <a:solidFill>
+                            <a:srgbClr val="2C2C6A"/>
+                          </a:solidFill>
                           <a:latin typeface="Times New Roman" panose="02020603050405020304" pitchFamily="18" charset="0"/>
                           <a:ea typeface="Tahoma" panose="020B0604030504040204" pitchFamily="34" charset="0"/>
                           <a:cs typeface="Times New Roman" panose="02020603050405020304" pitchFamily="18" charset="0"/>
                         </a:rPr>
                         <a:t> Group Member Name</a:t>
                       </a:r>
-                      <a:endParaRPr lang="en-US" sz="2800" dirty="0">
+                      <a:endParaRPr lang="en-US" sz="3200" b="1" dirty="0">
+                        <a:solidFill>
+                          <a:srgbClr val="2C2C6A"/>
+                        </a:solidFill>
                         <a:latin typeface="Times New Roman" panose="02020603050405020304" pitchFamily="18" charset="0"/>
                         <a:ea typeface="Tahoma" panose="020B0604030504040204" pitchFamily="34" charset="0"/>
                         <a:cs typeface="Times New Roman" panose="02020603050405020304" pitchFamily="18" charset="0"/>
@@ -3781,14 +3787,20 @@
                     <a:p>
                       <a:pPr algn="ctr"/>
                       <a:r>
-                        <a:rPr lang="en-US" sz="2800" dirty="0" smtClean="0">
+                        <a:rPr lang="en-US" sz="3200" b="1" dirty="0" smtClean="0">
+                          <a:solidFill>
+                            <a:srgbClr val="2C2C6A"/>
+                          </a:solidFill>
                           <a:latin typeface="Times New Roman" panose="02020603050405020304" pitchFamily="18" charset="0"/>
                           <a:ea typeface="Tahoma" panose="020B0604030504040204" pitchFamily="34" charset="0"/>
                           <a:cs typeface="Times New Roman" panose="02020603050405020304" pitchFamily="18" charset="0"/>
                         </a:rPr>
                         <a:t>Registration No</a:t>
                       </a:r>
-                      <a:endParaRPr lang="en-US" sz="2800" dirty="0">
+                      <a:endParaRPr lang="en-US" sz="3200" b="1" dirty="0">
+                        <a:solidFill>
+                          <a:srgbClr val="2C2C6A"/>
+                        </a:solidFill>
                         <a:latin typeface="Times New Roman" panose="02020603050405020304" pitchFamily="18" charset="0"/>
                         <a:ea typeface="Tahoma" panose="020B0604030504040204" pitchFamily="34" charset="0"/>
                         <a:cs typeface="Times New Roman" panose="02020603050405020304" pitchFamily="18" charset="0"/>
@@ -3806,19 +3818,23 @@
                     <a:p>
                       <a:pPr algn="ctr"/>
                       <a:r>
-                        <a:rPr sz="2000" b="1" dirty="0" smtClean="0">
+                        <a:rPr sz="2400" b="1" dirty="0" smtClean="0">
                           <a:solidFill>
                             <a:srgbClr val="2C2C6A"/>
                           </a:solidFill>
-                          <a:latin typeface="Times New Roman"/>
+                          <a:latin typeface="Times New Roman" panose="02020603050405020304" pitchFamily="18" charset="0"/>
+                          <a:ea typeface="Tahoma" panose="020B0604030504040204" pitchFamily="34" charset="0"/>
+                          <a:cs typeface="Times New Roman" panose="02020603050405020304" pitchFamily="18" charset="0"/>
                         </a:rPr>
                         <a:t>MOIZ AHMED</a:t>
                       </a:r>
-                      <a:endParaRPr sz="2000" b="1" dirty="0">
+                      <a:endParaRPr sz="2400" b="1" dirty="0">
                         <a:solidFill>
                           <a:srgbClr val="2C2C6A"/>
                         </a:solidFill>
-                        <a:latin typeface="Times New Roman"/>
+                        <a:latin typeface="Times New Roman" panose="02020603050405020304" pitchFamily="18" charset="0"/>
+                        <a:ea typeface="Tahoma" panose="020B0604030504040204" pitchFamily="34" charset="0"/>
+                        <a:cs typeface="Times New Roman" panose="02020603050405020304" pitchFamily="18" charset="0"/>
                       </a:endParaRPr>
                     </a:p>
                   </a:txBody>
@@ -3831,19 +3847,23 @@
                     <a:p>
                       <a:pPr algn="ctr"/>
                       <a:r>
-                        <a:rPr sz="2000" b="1" smtClean="0">
+                        <a:rPr sz="2400" b="1" smtClean="0">
                           <a:solidFill>
                             <a:srgbClr val="2C2C6A"/>
                           </a:solidFill>
-                          <a:latin typeface="Times New Roman"/>
+                          <a:latin typeface="Times New Roman" panose="02020603050405020304" pitchFamily="18" charset="0"/>
+                          <a:ea typeface="Tahoma" panose="020B0604030504040204" pitchFamily="34" charset="0"/>
+                          <a:cs typeface="Times New Roman" panose="02020603050405020304" pitchFamily="18" charset="0"/>
                         </a:rPr>
                         <a:t>S3F22UBSCS008</a:t>
                       </a:r>
-                      <a:endParaRPr sz="2000" b="1">
+                      <a:endParaRPr sz="2400" b="1">
                         <a:solidFill>
                           <a:srgbClr val="2C2C6A"/>
                         </a:solidFill>
-                        <a:latin typeface="Times New Roman"/>
+                        <a:latin typeface="Times New Roman" panose="02020603050405020304" pitchFamily="18" charset="0"/>
+                        <a:ea typeface="Tahoma" panose="020B0604030504040204" pitchFamily="34" charset="0"/>
+                        <a:cs typeface="Times New Roman" panose="02020603050405020304" pitchFamily="18" charset="0"/>
                       </a:endParaRPr>
                     </a:p>
                   </a:txBody>
@@ -3858,19 +3878,23 @@
                     <a:p>
                       <a:pPr algn="ctr"/>
                       <a:r>
-                        <a:rPr sz="2000" b="1" dirty="0" smtClean="0">
+                        <a:rPr sz="2400" b="1" dirty="0" smtClean="0">
                           <a:solidFill>
                             <a:srgbClr val="2C2C6A"/>
                           </a:solidFill>
-                          <a:latin typeface="Times New Roman"/>
+                          <a:latin typeface="Times New Roman" panose="02020603050405020304" pitchFamily="18" charset="0"/>
+                          <a:ea typeface="Tahoma" panose="020B0604030504040204" pitchFamily="34" charset="0"/>
+                          <a:cs typeface="Times New Roman" panose="02020603050405020304" pitchFamily="18" charset="0"/>
                         </a:rPr>
                         <a:t>BISSMA IJAZ</a:t>
                       </a:r>
-                      <a:endParaRPr sz="2000" b="1" dirty="0">
+                      <a:endParaRPr sz="2400" b="1" dirty="0">
                         <a:solidFill>
                           <a:srgbClr val="2C2C6A"/>
                         </a:solidFill>
-                        <a:latin typeface="Times New Roman"/>
+                        <a:latin typeface="Times New Roman" panose="02020603050405020304" pitchFamily="18" charset="0"/>
+                        <a:ea typeface="Tahoma" panose="020B0604030504040204" pitchFamily="34" charset="0"/>
+                        <a:cs typeface="Times New Roman" panose="02020603050405020304" pitchFamily="18" charset="0"/>
                       </a:endParaRPr>
                     </a:p>
                   </a:txBody>
@@ -3883,19 +3907,23 @@
                     <a:p>
                       <a:pPr algn="ctr"/>
                       <a:r>
-                        <a:rPr sz="2000" b="1" dirty="0" smtClean="0">
+                        <a:rPr sz="2400" b="1" dirty="0" smtClean="0">
                           <a:solidFill>
                             <a:srgbClr val="2C2C6A"/>
                           </a:solidFill>
-                          <a:latin typeface="Times New Roman"/>
+                          <a:latin typeface="Times New Roman" panose="02020603050405020304" pitchFamily="18" charset="0"/>
+                          <a:ea typeface="Tahoma" panose="020B0604030504040204" pitchFamily="34" charset="0"/>
+                          <a:cs typeface="Times New Roman" panose="02020603050405020304" pitchFamily="18" charset="0"/>
                         </a:rPr>
                         <a:t>S3F22UBSCS025</a:t>
                       </a:r>
-                      <a:endParaRPr sz="2000" b="1" dirty="0">
+                      <a:endParaRPr sz="2400" b="1" dirty="0">
                         <a:solidFill>
                           <a:srgbClr val="2C2C6A"/>
                         </a:solidFill>
-                        <a:latin typeface="Times New Roman"/>
+                        <a:latin typeface="Times New Roman" panose="02020603050405020304" pitchFamily="18" charset="0"/>
+                        <a:ea typeface="Tahoma" panose="020B0604030504040204" pitchFamily="34" charset="0"/>
+                        <a:cs typeface="Times New Roman" panose="02020603050405020304" pitchFamily="18" charset="0"/>
                       </a:endParaRPr>
                     </a:p>
                   </a:txBody>
@@ -3910,19 +3938,23 @@
                     <a:p>
                       <a:pPr algn="ctr"/>
                       <a:r>
-                        <a:rPr sz="2000" b="1" smtClean="0">
+                        <a:rPr sz="2400" b="1" smtClean="0">
                           <a:solidFill>
                             <a:srgbClr val="2C2C6A"/>
                           </a:solidFill>
-                          <a:latin typeface="Times New Roman"/>
+                          <a:latin typeface="Times New Roman" panose="02020603050405020304" pitchFamily="18" charset="0"/>
+                          <a:ea typeface="Tahoma" panose="020B0604030504040204" pitchFamily="34" charset="0"/>
+                          <a:cs typeface="Times New Roman" panose="02020603050405020304" pitchFamily="18" charset="0"/>
                         </a:rPr>
                         <a:t>ALI HAIDER</a:t>
                       </a:r>
-                      <a:endParaRPr sz="2000" b="1">
+                      <a:endParaRPr sz="2400" b="1">
                         <a:solidFill>
                           <a:srgbClr val="2C2C6A"/>
                         </a:solidFill>
-                        <a:latin typeface="Times New Roman"/>
+                        <a:latin typeface="Times New Roman" panose="02020603050405020304" pitchFamily="18" charset="0"/>
+                        <a:ea typeface="Tahoma" panose="020B0604030504040204" pitchFamily="34" charset="0"/>
+                        <a:cs typeface="Times New Roman" panose="02020603050405020304" pitchFamily="18" charset="0"/>
                       </a:endParaRPr>
                     </a:p>
                   </a:txBody>
@@ -3935,19 +3967,23 @@
                     <a:p>
                       <a:pPr algn="ctr"/>
                       <a:r>
-                        <a:rPr sz="2000" b="1" dirty="0" smtClean="0">
+                        <a:rPr sz="2400" b="1" dirty="0" smtClean="0">
                           <a:solidFill>
                             <a:srgbClr val="2C2C6A"/>
                           </a:solidFill>
-                          <a:latin typeface="Times New Roman"/>
+                          <a:latin typeface="Times New Roman" panose="02020603050405020304" pitchFamily="18" charset="0"/>
+                          <a:ea typeface="Tahoma" panose="020B0604030504040204" pitchFamily="34" charset="0"/>
+                          <a:cs typeface="Times New Roman" panose="02020603050405020304" pitchFamily="18" charset="0"/>
                         </a:rPr>
                         <a:t>S3F22UBSCS091</a:t>
                       </a:r>
-                      <a:endParaRPr sz="2000" b="1" dirty="0">
+                      <a:endParaRPr sz="2400" b="1" dirty="0">
                         <a:solidFill>
                           <a:srgbClr val="2C2C6A"/>
                         </a:solidFill>
-                        <a:latin typeface="Times New Roman"/>
+                        <a:latin typeface="Times New Roman" panose="02020603050405020304" pitchFamily="18" charset="0"/>
+                        <a:ea typeface="Tahoma" panose="020B0604030504040204" pitchFamily="34" charset="0"/>
+                        <a:cs typeface="Times New Roman" panose="02020603050405020304" pitchFamily="18" charset="0"/>
                       </a:endParaRPr>
                     </a:p>
                   </a:txBody>
@@ -4044,7 +4080,7 @@
             <a:blip r:embed="rId2">
               <a:extLst>
                 <a:ext uri="{96DAC541-7B7A-43D3-8B79-37D633B846F1}">
-                  <asvg:svgBlip xmlns:asvg="http://schemas.microsoft.com/office/drawing/2016/SVG/main" xmlns="" r:embed="rId3"/>
+                  <asvg:svgBlip xmlns="" xmlns:asvg="http://schemas.microsoft.com/office/drawing/2016/SVG/main" r:embed="rId3"/>
                 </a:ext>
               </a:extLst>
             </a:blip>
@@ -4096,7 +4132,7 @@
             <a:blip r:embed="rId2">
               <a:extLst>
                 <a:ext uri="{96DAC541-7B7A-43D3-8B79-37D633B846F1}">
-                  <asvg:svgBlip xmlns:asvg="http://schemas.microsoft.com/office/drawing/2016/SVG/main" xmlns="" r:embed="rId3"/>
+                  <asvg:svgBlip xmlns="" xmlns:asvg="http://schemas.microsoft.com/office/drawing/2016/SVG/main" r:embed="rId3"/>
                 </a:ext>
               </a:extLst>
             </a:blip>
@@ -4473,7 +4509,7 @@
             <a:blip r:embed="rId2">
               <a:extLst>
                 <a:ext uri="{96DAC541-7B7A-43D3-8B79-37D633B846F1}">
-                  <asvg:svgBlip xmlns:asvg="http://schemas.microsoft.com/office/drawing/2016/SVG/main" xmlns="" r:embed="rId3"/>
+                  <asvg:svgBlip xmlns="" xmlns:asvg="http://schemas.microsoft.com/office/drawing/2016/SVG/main" r:embed="rId3"/>
                 </a:ext>
               </a:extLst>
             </a:blip>
@@ -4525,7 +4561,7 @@
             <a:blip r:embed="rId2">
               <a:extLst>
                 <a:ext uri="{96DAC541-7B7A-43D3-8B79-37D633B846F1}">
-                  <asvg:svgBlip xmlns:asvg="http://schemas.microsoft.com/office/drawing/2016/SVG/main" xmlns="" r:embed="rId3"/>
+                  <asvg:svgBlip xmlns="" xmlns:asvg="http://schemas.microsoft.com/office/drawing/2016/SVG/main" r:embed="rId3"/>
                 </a:ext>
               </a:extLst>
             </a:blip>
@@ -4952,7 +4988,7 @@
             <a:blip r:embed="rId2">
               <a:extLst>
                 <a:ext uri="{96DAC541-7B7A-43D3-8B79-37D633B846F1}">
-                  <asvg:svgBlip xmlns:asvg="http://schemas.microsoft.com/office/drawing/2016/SVG/main" xmlns="" r:embed="rId3"/>
+                  <asvg:svgBlip xmlns="" xmlns:asvg="http://schemas.microsoft.com/office/drawing/2016/SVG/main" r:embed="rId3"/>
                 </a:ext>
               </a:extLst>
             </a:blip>
@@ -5004,7 +5040,7 @@
             <a:blip r:embed="rId2">
               <a:extLst>
                 <a:ext uri="{96DAC541-7B7A-43D3-8B79-37D633B846F1}">
-                  <asvg:svgBlip xmlns:asvg="http://schemas.microsoft.com/office/drawing/2016/SVG/main" xmlns="" r:embed="rId3"/>
+                  <asvg:svgBlip xmlns="" xmlns:asvg="http://schemas.microsoft.com/office/drawing/2016/SVG/main" r:embed="rId3"/>
                 </a:ext>
               </a:extLst>
             </a:blip>
@@ -5411,7 +5447,7 @@
             <a:blip r:embed="rId2">
               <a:extLst>
                 <a:ext uri="{96DAC541-7B7A-43D3-8B79-37D633B846F1}">
-                  <asvg:svgBlip xmlns:asvg="http://schemas.microsoft.com/office/drawing/2016/SVG/main" xmlns="" r:embed="rId3"/>
+                  <asvg:svgBlip xmlns="" xmlns:asvg="http://schemas.microsoft.com/office/drawing/2016/SVG/main" r:embed="rId3"/>
                 </a:ext>
               </a:extLst>
             </a:blip>
@@ -5463,7 +5499,7 @@
             <a:blip r:embed="rId2">
               <a:extLst>
                 <a:ext uri="{96DAC541-7B7A-43D3-8B79-37D633B846F1}">
-                  <asvg:svgBlip xmlns:asvg="http://schemas.microsoft.com/office/drawing/2016/SVG/main" xmlns="" r:embed="rId3"/>
+                  <asvg:svgBlip xmlns="" xmlns:asvg="http://schemas.microsoft.com/office/drawing/2016/SVG/main" r:embed="rId3"/>
                 </a:ext>
               </a:extLst>
             </a:blip>
@@ -5821,7 +5857,7 @@
             <a:blip r:embed="rId2">
               <a:extLst>
                 <a:ext uri="{96DAC541-7B7A-43D3-8B79-37D633B846F1}">
-                  <asvg:svgBlip xmlns:asvg="http://schemas.microsoft.com/office/drawing/2016/SVG/main" xmlns="" r:embed="rId3"/>
+                  <asvg:svgBlip xmlns="" xmlns:asvg="http://schemas.microsoft.com/office/drawing/2016/SVG/main" r:embed="rId3"/>
                 </a:ext>
               </a:extLst>
             </a:blip>
@@ -5873,7 +5909,7 @@
             <a:blip r:embed="rId2">
               <a:extLst>
                 <a:ext uri="{96DAC541-7B7A-43D3-8B79-37D633B846F1}">
-                  <asvg:svgBlip xmlns:asvg="http://schemas.microsoft.com/office/drawing/2016/SVG/main" xmlns="" r:embed="rId3"/>
+                  <asvg:svgBlip xmlns="" xmlns:asvg="http://schemas.microsoft.com/office/drawing/2016/SVG/main" r:embed="rId3"/>
                 </a:ext>
               </a:extLst>
             </a:blip>
@@ -6252,7 +6288,7 @@
             <a:blip r:embed="rId4">
               <a:extLst>
                 <a:ext uri="{96DAC541-7B7A-43D3-8B79-37D633B846F1}">
-                  <asvg:svgBlip xmlns:asvg="http://schemas.microsoft.com/office/drawing/2016/SVG/main" xmlns="" r:embed="rId5"/>
+                  <asvg:svgBlip xmlns="" xmlns:asvg="http://schemas.microsoft.com/office/drawing/2016/SVG/main" r:embed="rId5"/>
                 </a:ext>
               </a:extLst>
             </a:blip>
@@ -6430,7 +6466,7 @@
             <a:blip r:embed="rId4">
               <a:extLst>
                 <a:ext uri="{96DAC541-7B7A-43D3-8B79-37D633B846F1}">
-                  <asvg:svgBlip xmlns:asvg="http://schemas.microsoft.com/office/drawing/2016/SVG/main" xmlns="" r:embed="rId5"/>
+                  <asvg:svgBlip xmlns="" xmlns:asvg="http://schemas.microsoft.com/office/drawing/2016/SVG/main" r:embed="rId5"/>
                 </a:ext>
               </a:extLst>
             </a:blip>
@@ -6560,7 +6596,7 @@
             <a:blip r:embed="rId6">
               <a:extLst>
                 <a:ext uri="{96DAC541-7B7A-43D3-8B79-37D633B846F1}">
-                  <asvg:svgBlip xmlns:asvg="http://schemas.microsoft.com/office/drawing/2016/SVG/main" xmlns="" r:embed="rId7"/>
+                  <asvg:svgBlip xmlns="" xmlns:asvg="http://schemas.microsoft.com/office/drawing/2016/SVG/main" r:embed="rId7"/>
                 </a:ext>
               </a:extLst>
             </a:blip>
@@ -6761,7 +6797,7 @@
             <a:blip r:embed="rId2">
               <a:extLst>
                 <a:ext uri="{96DAC541-7B7A-43D3-8B79-37D633B846F1}">
-                  <asvg:svgBlip xmlns:asvg="http://schemas.microsoft.com/office/drawing/2016/SVG/main" xmlns="" r:embed="rId4"/>
+                  <asvg:svgBlip xmlns="" xmlns:asvg="http://schemas.microsoft.com/office/drawing/2016/SVG/main" r:embed="rId4"/>
                 </a:ext>
               </a:extLst>
             </a:blip>
@@ -7241,7 +7277,7 @@
             <a:blip r:embed="rId2">
               <a:extLst>
                 <a:ext uri="{96DAC541-7B7A-43D3-8B79-37D633B846F1}">
-                  <asvg:svgBlip xmlns:asvg="http://schemas.microsoft.com/office/drawing/2016/SVG/main" xmlns="" r:embed="rId4"/>
+                  <asvg:svgBlip xmlns="" xmlns:asvg="http://schemas.microsoft.com/office/drawing/2016/SVG/main" r:embed="rId4"/>
                 </a:ext>
               </a:extLst>
             </a:blip>
@@ -7724,7 +7760,7 @@
             <a:blip r:embed="rId2">
               <a:extLst>
                 <a:ext uri="{96DAC541-7B7A-43D3-8B79-37D633B846F1}">
-                  <asvg:svgBlip xmlns:asvg="http://schemas.microsoft.com/office/drawing/2016/SVG/main" xmlns="" r:embed="rId3"/>
+                  <asvg:svgBlip xmlns="" xmlns:asvg="http://schemas.microsoft.com/office/drawing/2016/SVG/main" r:embed="rId3"/>
                 </a:ext>
               </a:extLst>
             </a:blip>
@@ -7776,7 +7812,7 @@
             <a:blip r:embed="rId2">
               <a:extLst>
                 <a:ext uri="{96DAC541-7B7A-43D3-8B79-37D633B846F1}">
-                  <asvg:svgBlip xmlns:asvg="http://schemas.microsoft.com/office/drawing/2016/SVG/main" xmlns="" r:embed="rId3"/>
+                  <asvg:svgBlip xmlns="" xmlns:asvg="http://schemas.microsoft.com/office/drawing/2016/SVG/main" r:embed="rId3"/>
                 </a:ext>
               </a:extLst>
             </a:blip>
@@ -8056,7 +8092,7 @@
             <a:blip r:embed="rId4">
               <a:extLst>
                 <a:ext uri="{96DAC541-7B7A-43D3-8B79-37D633B846F1}">
-                  <asvg:svgBlip xmlns:asvg="http://schemas.microsoft.com/office/drawing/2016/SVG/main" xmlns="" r:embed="rId5"/>
+                  <asvg:svgBlip xmlns="" xmlns:asvg="http://schemas.microsoft.com/office/drawing/2016/SVG/main" r:embed="rId5"/>
                 </a:ext>
               </a:extLst>
             </a:blip>
@@ -8104,14 +8140,7 @@
                 <a:latin typeface="Times New Roman" panose="02020603050405020304" pitchFamily="18" charset="0"/>
                 <a:cs typeface="Times New Roman" panose="02020603050405020304" pitchFamily="18" charset="0"/>
               </a:rPr>
-              <a:t>All </a:t>
-            </a:r>
-            <a:r>
-              <a:rPr lang="en-US" sz="2400" dirty="0">
-                <a:latin typeface="Times New Roman" panose="02020603050405020304" pitchFamily="18" charset="0"/>
-                <a:cs typeface="Times New Roman" panose="02020603050405020304" pitchFamily="18" charset="0"/>
-              </a:rPr>
-              <a:t>t</a:t>
+              <a:t>All t</a:t>
             </a:r>
             <a:r>
               <a:rPr lang="en-US" sz="2400" dirty="0" smtClean="0">
@@ -8202,7 +8231,7 @@
             <a:blip r:embed="rId4">
               <a:extLst>
                 <a:ext uri="{96DAC541-7B7A-43D3-8B79-37D633B846F1}">
-                  <asvg:svgBlip xmlns:asvg="http://schemas.microsoft.com/office/drawing/2016/SVG/main" xmlns="" r:embed="rId5"/>
+                  <asvg:svgBlip xmlns="" xmlns:asvg="http://schemas.microsoft.com/office/drawing/2016/SVG/main" r:embed="rId5"/>
                 </a:ext>
               </a:extLst>
             </a:blip>
@@ -8318,7 +8347,7 @@
             <a:blip r:embed="rId6">
               <a:extLst>
                 <a:ext uri="{96DAC541-7B7A-43D3-8B79-37D633B846F1}">
-                  <asvg:svgBlip xmlns:asvg="http://schemas.microsoft.com/office/drawing/2016/SVG/main" xmlns="" r:embed="rId7"/>
+                  <asvg:svgBlip xmlns="" xmlns:asvg="http://schemas.microsoft.com/office/drawing/2016/SVG/main" r:embed="rId7"/>
                 </a:ext>
               </a:extLst>
             </a:blip>
@@ -8430,13 +8459,13 @@
   <p:clrMapOvr>
     <a:masterClrMapping/>
   </p:clrMapOvr>
-  <mc:AlternateContent xmlns:mc="http://schemas.openxmlformats.org/markup-compatibility/2006">
-    <mc:Choice xmlns:p14="http://schemas.microsoft.com/office/powerpoint/2010/main" Requires="p14">
+  <mc:AlternateContent xmlns:mc="http://schemas.openxmlformats.org/markup-compatibility/2006" xmlns:p14="http://schemas.microsoft.com/office/powerpoint/2010/main">
+    <mc:Choice Requires="p14">
       <p:transition spd="med" p14:dur="700">
         <p:fade/>
       </p:transition>
     </mc:Choice>
-    <mc:Fallback>
+    <mc:Fallback xmlns="">
       <p:transition spd="med">
         <p:fade/>
       </p:transition>
@@ -8511,7 +8540,7 @@
             <a:blip r:embed="rId2">
               <a:extLst>
                 <a:ext uri="{96DAC541-7B7A-43D3-8B79-37D633B846F1}">
-                  <asvg:svgBlip xmlns:asvg="http://schemas.microsoft.com/office/drawing/2016/SVG/main" xmlns="" r:embed="rId3"/>
+                  <asvg:svgBlip xmlns="" xmlns:asvg="http://schemas.microsoft.com/office/drawing/2016/SVG/main" r:embed="rId3"/>
                 </a:ext>
               </a:extLst>
             </a:blip>
@@ -8646,7 +8675,7 @@
             <a:blip r:embed="rId2">
               <a:extLst>
                 <a:ext uri="{96DAC541-7B7A-43D3-8B79-37D633B846F1}">
-                  <asvg:svgBlip xmlns:asvg="http://schemas.microsoft.com/office/drawing/2016/SVG/main" xmlns="" r:embed="rId3"/>
+                  <asvg:svgBlip xmlns="" xmlns:asvg="http://schemas.microsoft.com/office/drawing/2016/SVG/main" r:embed="rId3"/>
                 </a:ext>
               </a:extLst>
             </a:blip>
@@ -8741,14 +8770,7 @@
                 <a:latin typeface="Times New Roman" panose="02020603050405020304" pitchFamily="18" charset="0"/>
                 <a:cs typeface="Times New Roman" panose="02020603050405020304" pitchFamily="18" charset="0"/>
               </a:rPr>
-              <a:t> </a:t>
-            </a:r>
-            <a:r>
-              <a:rPr lang="en-US" sz="2400" dirty="0">
-                <a:latin typeface="Times New Roman" panose="02020603050405020304" pitchFamily="18" charset="0"/>
-                <a:cs typeface="Times New Roman" panose="02020603050405020304" pitchFamily="18" charset="0"/>
-              </a:rPr>
-              <a:t>C</a:t>
+              <a:t> C</a:t>
             </a:r>
             <a:r>
               <a:rPr lang="en-US" sz="2400" dirty="0" smtClean="0">
@@ -9235,7 +9257,7 @@
             <a:blip r:embed="rId4">
               <a:extLst>
                 <a:ext uri="{96DAC541-7B7A-43D3-8B79-37D633B846F1}">
-                  <asvg:svgBlip xmlns:asvg="http://schemas.microsoft.com/office/drawing/2016/SVG/main" xmlns="" r:embed="rId5"/>
+                  <asvg:svgBlip xmlns="" xmlns:asvg="http://schemas.microsoft.com/office/drawing/2016/SVG/main" r:embed="rId5"/>
                 </a:ext>
               </a:extLst>
             </a:blip>
@@ -9287,7 +9309,7 @@
             <a:blip r:embed="rId6">
               <a:extLst>
                 <a:ext uri="{96DAC541-7B7A-43D3-8B79-37D633B846F1}">
-                  <asvg:svgBlip xmlns:asvg="http://schemas.microsoft.com/office/drawing/2016/SVG/main" xmlns="" r:embed="rId7"/>
+                  <asvg:svgBlip xmlns="" xmlns:asvg="http://schemas.microsoft.com/office/drawing/2016/SVG/main" r:embed="rId7"/>
                 </a:ext>
               </a:extLst>
             </a:blip>
@@ -9411,13 +9433,13 @@
   <p:clrMapOvr>
     <a:masterClrMapping/>
   </p:clrMapOvr>
-  <mc:AlternateContent xmlns:mc="http://schemas.openxmlformats.org/markup-compatibility/2006">
-    <mc:Choice xmlns:p14="http://schemas.microsoft.com/office/powerpoint/2010/main" Requires="p14">
+  <mc:AlternateContent xmlns:mc="http://schemas.openxmlformats.org/markup-compatibility/2006" xmlns:p14="http://schemas.microsoft.com/office/powerpoint/2010/main">
+    <mc:Choice Requires="p14">
       <p:transition spd="med" p14:dur="700">
         <p:fade/>
       </p:transition>
     </mc:Choice>
-    <mc:Fallback>
+    <mc:Fallback xmlns="">
       <p:transition spd="med">
         <p:fade/>
       </p:transition>
@@ -9627,7 +9649,7 @@
             <a:blip r:embed="rId2">
               <a:extLst>
                 <a:ext uri="{96DAC541-7B7A-43D3-8B79-37D633B846F1}">
-                  <asvg:svgBlip xmlns:asvg="http://schemas.microsoft.com/office/drawing/2016/SVG/main" xmlns="" r:embed="rId3"/>
+                  <asvg:svgBlip xmlns="" xmlns:asvg="http://schemas.microsoft.com/office/drawing/2016/SVG/main" r:embed="rId3"/>
                 </a:ext>
               </a:extLst>
             </a:blip>
@@ -9679,7 +9701,7 @@
             <a:blip r:embed="rId2">
               <a:extLst>
                 <a:ext uri="{96DAC541-7B7A-43D3-8B79-37D633B846F1}">
-                  <asvg:svgBlip xmlns:asvg="http://schemas.microsoft.com/office/drawing/2016/SVG/main" xmlns="" r:embed="rId3"/>
+                  <asvg:svgBlip xmlns="" xmlns:asvg="http://schemas.microsoft.com/office/drawing/2016/SVG/main" r:embed="rId3"/>
                 </a:ext>
               </a:extLst>
             </a:blip>
@@ -9979,7 +10001,7 @@
             <a:blip r:embed="rId4">
               <a:extLst>
                 <a:ext uri="{96DAC541-7B7A-43D3-8B79-37D633B846F1}">
-                  <asvg:svgBlip xmlns:asvg="http://schemas.microsoft.com/office/drawing/2016/SVG/main" xmlns="" r:embed="rId5"/>
+                  <asvg:svgBlip xmlns="" xmlns:asvg="http://schemas.microsoft.com/office/drawing/2016/SVG/main" r:embed="rId5"/>
                 </a:ext>
               </a:extLst>
             </a:blip>
@@ -10158,7 +10180,7 @@
             <a:blip r:embed="rId4">
               <a:extLst>
                 <a:ext uri="{96DAC541-7B7A-43D3-8B79-37D633B846F1}">
-                  <asvg:svgBlip xmlns:asvg="http://schemas.microsoft.com/office/drawing/2016/SVG/main" xmlns="" r:embed="rId5"/>
+                  <asvg:svgBlip xmlns="" xmlns:asvg="http://schemas.microsoft.com/office/drawing/2016/SVG/main" r:embed="rId5"/>
                 </a:ext>
               </a:extLst>
             </a:blip>
@@ -10351,7 +10373,7 @@
             <a:blip r:embed="rId6">
               <a:extLst>
                 <a:ext uri="{96DAC541-7B7A-43D3-8B79-37D633B846F1}">
-                  <asvg:svgBlip xmlns:asvg="http://schemas.microsoft.com/office/drawing/2016/SVG/main" xmlns="" r:embed="rId7"/>
+                  <asvg:svgBlip xmlns="" xmlns:asvg="http://schemas.microsoft.com/office/drawing/2016/SVG/main" r:embed="rId7"/>
                 </a:ext>
               </a:extLst>
             </a:blip>
@@ -10463,13 +10485,13 @@
   <p:clrMapOvr>
     <a:masterClrMapping/>
   </p:clrMapOvr>
-  <mc:AlternateContent xmlns:mc="http://schemas.openxmlformats.org/markup-compatibility/2006">
-    <mc:Choice xmlns:p14="http://schemas.microsoft.com/office/powerpoint/2010/main" Requires="p14">
+  <mc:AlternateContent xmlns:mc="http://schemas.openxmlformats.org/markup-compatibility/2006" xmlns:p14="http://schemas.microsoft.com/office/powerpoint/2010/main">
+    <mc:Choice Requires="p14">
       <p:transition spd="med" p14:dur="700">
         <p:fade/>
       </p:transition>
     </mc:Choice>
-    <mc:Fallback>
+    <mc:Fallback xmlns="">
       <p:transition spd="med">
         <p:fade/>
       </p:transition>
@@ -10544,7 +10566,7 @@
             <a:blip r:embed="rId2">
               <a:extLst>
                 <a:ext uri="{96DAC541-7B7A-43D3-8B79-37D633B846F1}">
-                  <asvg:svgBlip xmlns:asvg="http://schemas.microsoft.com/office/drawing/2016/SVG/main" xmlns="" r:embed="rId3"/>
+                  <asvg:svgBlip xmlns="" xmlns:asvg="http://schemas.microsoft.com/office/drawing/2016/SVG/main" r:embed="rId3"/>
                 </a:ext>
               </a:extLst>
             </a:blip>
@@ -10596,7 +10618,7 @@
             <a:blip r:embed="rId2">
               <a:extLst>
                 <a:ext uri="{96DAC541-7B7A-43D3-8B79-37D633B846F1}">
-                  <asvg:svgBlip xmlns:asvg="http://schemas.microsoft.com/office/drawing/2016/SVG/main" xmlns="" r:embed="rId3"/>
+                  <asvg:svgBlip xmlns="" xmlns:asvg="http://schemas.microsoft.com/office/drawing/2016/SVG/main" r:embed="rId3"/>
                 </a:ext>
               </a:extLst>
             </a:blip>
@@ -10923,7 +10945,7 @@
             <a:blip r:embed="rId4">
               <a:extLst>
                 <a:ext uri="{96DAC541-7B7A-43D3-8B79-37D633B846F1}">
-                  <asvg:svgBlip xmlns:asvg="http://schemas.microsoft.com/office/drawing/2016/SVG/main" xmlns="" r:embed="rId5"/>
+                  <asvg:svgBlip xmlns="" xmlns:asvg="http://schemas.microsoft.com/office/drawing/2016/SVG/main" r:embed="rId5"/>
                 </a:ext>
               </a:extLst>
             </a:blip>
@@ -11083,7 +11105,7 @@
             <a:blip r:embed="rId4">
               <a:extLst>
                 <a:ext uri="{96DAC541-7B7A-43D3-8B79-37D633B846F1}">
-                  <asvg:svgBlip xmlns:asvg="http://schemas.microsoft.com/office/drawing/2016/SVG/main" xmlns="" r:embed="rId5"/>
+                  <asvg:svgBlip xmlns="" xmlns:asvg="http://schemas.microsoft.com/office/drawing/2016/SVG/main" r:embed="rId5"/>
                 </a:ext>
               </a:extLst>
             </a:blip>
@@ -11243,7 +11265,7 @@
             <a:blip r:embed="rId6">
               <a:extLst>
                 <a:ext uri="{96DAC541-7B7A-43D3-8B79-37D633B846F1}">
-                  <asvg:svgBlip xmlns:asvg="http://schemas.microsoft.com/office/drawing/2016/SVG/main" xmlns="" r:embed="rId7"/>
+                  <asvg:svgBlip xmlns="" xmlns:asvg="http://schemas.microsoft.com/office/drawing/2016/SVG/main" r:embed="rId7"/>
                 </a:ext>
               </a:extLst>
             </a:blip>
@@ -11427,7 +11449,7 @@
             <a:blip r:embed="rId2">
               <a:extLst>
                 <a:ext uri="{96DAC541-7B7A-43D3-8B79-37D633B846F1}">
-                  <asvg:svgBlip xmlns:asvg="http://schemas.microsoft.com/office/drawing/2016/SVG/main" xmlns="" r:embed="rId3"/>
+                  <asvg:svgBlip xmlns="" xmlns:asvg="http://schemas.microsoft.com/office/drawing/2016/SVG/main" r:embed="rId3"/>
                 </a:ext>
               </a:extLst>
             </a:blip>
@@ -11479,7 +11501,7 @@
             <a:blip r:embed="rId2">
               <a:extLst>
                 <a:ext uri="{96DAC541-7B7A-43D3-8B79-37D633B846F1}">
-                  <asvg:svgBlip xmlns:asvg="http://schemas.microsoft.com/office/drawing/2016/SVG/main" xmlns="" r:embed="rId3"/>
+                  <asvg:svgBlip xmlns="" xmlns:asvg="http://schemas.microsoft.com/office/drawing/2016/SVG/main" r:embed="rId3"/>
                 </a:ext>
               </a:extLst>
             </a:blip>
@@ -11746,7 +11768,7 @@
             <a:blip r:embed="rId4">
               <a:extLst>
                 <a:ext uri="{96DAC541-7B7A-43D3-8B79-37D633B846F1}">
-                  <asvg:svgBlip xmlns:asvg="http://schemas.microsoft.com/office/drawing/2016/SVG/main" xmlns="" r:embed="rId5"/>
+                  <asvg:svgBlip xmlns="" xmlns:asvg="http://schemas.microsoft.com/office/drawing/2016/SVG/main" r:embed="rId5"/>
                 </a:ext>
               </a:extLst>
             </a:blip>
@@ -11906,7 +11928,7 @@
             <a:blip r:embed="rId4">
               <a:extLst>
                 <a:ext uri="{96DAC541-7B7A-43D3-8B79-37D633B846F1}">
-                  <asvg:svgBlip xmlns:asvg="http://schemas.microsoft.com/office/drawing/2016/SVG/main" xmlns="" r:embed="rId5"/>
+                  <asvg:svgBlip xmlns="" xmlns:asvg="http://schemas.microsoft.com/office/drawing/2016/SVG/main" r:embed="rId5"/>
                 </a:ext>
               </a:extLst>
             </a:blip>
@@ -12036,7 +12058,7 @@
             <a:blip r:embed="rId6">
               <a:extLst>
                 <a:ext uri="{96DAC541-7B7A-43D3-8B79-37D633B846F1}">
-                  <asvg:svgBlip xmlns:asvg="http://schemas.microsoft.com/office/drawing/2016/SVG/main" xmlns="" r:embed="rId7"/>
+                  <asvg:svgBlip xmlns="" xmlns:asvg="http://schemas.microsoft.com/office/drawing/2016/SVG/main" r:embed="rId7"/>
                 </a:ext>
               </a:extLst>
             </a:blip>
@@ -12116,13 +12138,13 @@
   <p:clrMapOvr>
     <a:masterClrMapping/>
   </p:clrMapOvr>
-  <mc:AlternateContent xmlns:mc="http://schemas.openxmlformats.org/markup-compatibility/2006">
-    <mc:Choice xmlns:p14="http://schemas.microsoft.com/office/powerpoint/2010/main" Requires="p14">
+  <mc:AlternateContent xmlns:mc="http://schemas.openxmlformats.org/markup-compatibility/2006" xmlns:p14="http://schemas.microsoft.com/office/powerpoint/2010/main">
+    <mc:Choice Requires="p14">
       <p:transition spd="med" p14:dur="700">
         <p:fade/>
       </p:transition>
     </mc:Choice>
-    <mc:Fallback>
+    <mc:Fallback xmlns="">
       <p:transition spd="med">
         <p:fade/>
       </p:transition>
@@ -12359,13 +12381,13 @@
   <p:clrMapOvr>
     <a:masterClrMapping/>
   </p:clrMapOvr>
-  <mc:AlternateContent xmlns:mc="http://schemas.openxmlformats.org/markup-compatibility/2006">
-    <mc:Choice xmlns:p14="http://schemas.microsoft.com/office/powerpoint/2010/main" Requires="p14">
+  <mc:AlternateContent xmlns:mc="http://schemas.openxmlformats.org/markup-compatibility/2006" xmlns:p14="http://schemas.microsoft.com/office/powerpoint/2010/main">
+    <mc:Choice Requires="p14">
       <p:transition spd="med" p14:dur="700">
         <p:fade/>
       </p:transition>
     </mc:Choice>
-    <mc:Fallback>
+    <mc:Fallback xmlns="">
       <p:transition spd="med">
         <p:fade/>
       </p:transition>
@@ -12440,7 +12462,7 @@
             <a:blip r:embed="rId2">
               <a:extLst>
                 <a:ext uri="{96DAC541-7B7A-43D3-8B79-37D633B846F1}">
-                  <asvg:svgBlip xmlns:asvg="http://schemas.microsoft.com/office/drawing/2016/SVG/main" xmlns="" r:embed="rId3"/>
+                  <asvg:svgBlip xmlns="" xmlns:asvg="http://schemas.microsoft.com/office/drawing/2016/SVG/main" r:embed="rId3"/>
                 </a:ext>
               </a:extLst>
             </a:blip>
@@ -12492,7 +12514,7 @@
             <a:blip r:embed="rId2">
               <a:extLst>
                 <a:ext uri="{96DAC541-7B7A-43D3-8B79-37D633B846F1}">
-                  <asvg:svgBlip xmlns:asvg="http://schemas.microsoft.com/office/drawing/2016/SVG/main" xmlns="" r:embed="rId3"/>
+                  <asvg:svgBlip xmlns="" xmlns:asvg="http://schemas.microsoft.com/office/drawing/2016/SVG/main" r:embed="rId3"/>
                 </a:ext>
               </a:extLst>
             </a:blip>
@@ -12751,7 +12773,7 @@
             <a:blip r:embed="rId4">
               <a:extLst>
                 <a:ext uri="{96DAC541-7B7A-43D3-8B79-37D633B846F1}">
-                  <asvg:svgBlip xmlns:asvg="http://schemas.microsoft.com/office/drawing/2016/SVG/main" xmlns="" r:embed="rId5"/>
+                  <asvg:svgBlip xmlns="" xmlns:asvg="http://schemas.microsoft.com/office/drawing/2016/SVG/main" r:embed="rId5"/>
                 </a:ext>
               </a:extLst>
             </a:blip>
@@ -12863,7 +12885,7 @@
             <a:blip r:embed="rId4">
               <a:extLst>
                 <a:ext uri="{96DAC541-7B7A-43D3-8B79-37D633B846F1}">
-                  <asvg:svgBlip xmlns:asvg="http://schemas.microsoft.com/office/drawing/2016/SVG/main" xmlns="" r:embed="rId5"/>
+                  <asvg:svgBlip xmlns="" xmlns:asvg="http://schemas.microsoft.com/office/drawing/2016/SVG/main" r:embed="rId5"/>
                 </a:ext>
               </a:extLst>
             </a:blip>
@@ -12996,7 +13018,7 @@
             <a:blip r:embed="rId6">
               <a:extLst>
                 <a:ext uri="{96DAC541-7B7A-43D3-8B79-37D633B846F1}">
-                  <asvg:svgBlip xmlns:asvg="http://schemas.microsoft.com/office/drawing/2016/SVG/main" xmlns="" r:embed="rId7"/>
+                  <asvg:svgBlip xmlns="" xmlns:asvg="http://schemas.microsoft.com/office/drawing/2016/SVG/main" r:embed="rId7"/>
                 </a:ext>
               </a:extLst>
             </a:blip>
@@ -13180,7 +13202,7 @@
             <a:blip r:embed="rId2">
               <a:extLst>
                 <a:ext uri="{96DAC541-7B7A-43D3-8B79-37D633B846F1}">
-                  <asvg:svgBlip xmlns:asvg="http://schemas.microsoft.com/office/drawing/2016/SVG/main" xmlns="" r:embed="rId3"/>
+                  <asvg:svgBlip xmlns="" xmlns:asvg="http://schemas.microsoft.com/office/drawing/2016/SVG/main" r:embed="rId3"/>
                 </a:ext>
               </a:extLst>
             </a:blip>
@@ -13232,7 +13254,7 @@
             <a:blip r:embed="rId2">
               <a:extLst>
                 <a:ext uri="{96DAC541-7B7A-43D3-8B79-37D633B846F1}">
-                  <asvg:svgBlip xmlns:asvg="http://schemas.microsoft.com/office/drawing/2016/SVG/main" xmlns="" r:embed="rId3"/>
+                  <asvg:svgBlip xmlns="" xmlns:asvg="http://schemas.microsoft.com/office/drawing/2016/SVG/main" r:embed="rId3"/>
                 </a:ext>
               </a:extLst>
             </a:blip>
@@ -13444,7 +13466,7 @@
             <a:blip r:embed="rId4">
               <a:extLst>
                 <a:ext uri="{96DAC541-7B7A-43D3-8B79-37D633B846F1}">
-                  <asvg:svgBlip xmlns:asvg="http://schemas.microsoft.com/office/drawing/2016/SVG/main" xmlns="" r:embed="rId5"/>
+                  <asvg:svgBlip xmlns="" xmlns:asvg="http://schemas.microsoft.com/office/drawing/2016/SVG/main" r:embed="rId5"/>
                 </a:ext>
               </a:extLst>
             </a:blip>
@@ -13584,7 +13606,7 @@
             <a:blip r:embed="rId4">
               <a:extLst>
                 <a:ext uri="{96DAC541-7B7A-43D3-8B79-37D633B846F1}">
-                  <asvg:svgBlip xmlns:asvg="http://schemas.microsoft.com/office/drawing/2016/SVG/main" xmlns="" r:embed="rId5"/>
+                  <asvg:svgBlip xmlns="" xmlns:asvg="http://schemas.microsoft.com/office/drawing/2016/SVG/main" r:embed="rId5"/>
                 </a:ext>
               </a:extLst>
             </a:blip>
@@ -13710,7 +13732,7 @@
             <a:blip r:embed="rId6">
               <a:extLst>
                 <a:ext uri="{96DAC541-7B7A-43D3-8B79-37D633B846F1}">
-                  <asvg:svgBlip xmlns:asvg="http://schemas.microsoft.com/office/drawing/2016/SVG/main" xmlns="" r:embed="rId7"/>
+                  <asvg:svgBlip xmlns="" xmlns:asvg="http://schemas.microsoft.com/office/drawing/2016/SVG/main" r:embed="rId7"/>
                 </a:ext>
               </a:extLst>
             </a:blip>
@@ -14410,7 +14432,7 @@
             <a:blip r:embed="rId2">
               <a:extLst>
                 <a:ext uri="{96DAC541-7B7A-43D3-8B79-37D633B846F1}">
-                  <asvg:svgBlip xmlns:asvg="http://schemas.microsoft.com/office/drawing/2016/SVG/main" xmlns="" r:embed="rId3"/>
+                  <asvg:svgBlip xmlns="" xmlns:asvg="http://schemas.microsoft.com/office/drawing/2016/SVG/main" r:embed="rId3"/>
                 </a:ext>
               </a:extLst>
             </a:blip>
@@ -14428,7 +14450,7 @@
         </p:nvGrpSpPr>
         <p:grpSpPr>
           <a:xfrm>
-            <a:off x="9144000" y="0"/>
+            <a:off x="9144000" y="114300"/>
             <a:ext cx="9144000" cy="10287000"/>
             <a:chOff x="0" y="0"/>
             <a:chExt cx="2408296" cy="2709333"/>
@@ -14545,7 +14567,7 @@
             <a:blip r:embed="rId2">
               <a:extLst>
                 <a:ext uri="{96DAC541-7B7A-43D3-8B79-37D633B846F1}">
-                  <asvg:svgBlip xmlns:asvg="http://schemas.microsoft.com/office/drawing/2016/SVG/main" xmlns="" r:embed="rId3"/>
+                  <asvg:svgBlip xmlns="" xmlns:asvg="http://schemas.microsoft.com/office/drawing/2016/SVG/main" r:embed="rId3"/>
                 </a:ext>
               </a:extLst>
             </a:blip>
@@ -14654,7 +14676,7 @@
         </p:nvSpPr>
         <p:spPr>
           <a:xfrm>
-            <a:off x="9406994" y="858849"/>
+            <a:off x="9406994" y="838320"/>
             <a:ext cx="6463811" cy="859210"/>
           </a:xfrm>
           <a:prstGeom prst="rect">
@@ -14779,7 +14801,7 @@
             <a:blip r:embed="rId4">
               <a:extLst>
                 <a:ext uri="{96DAC541-7B7A-43D3-8B79-37D633B846F1}">
-                  <asvg:svgBlip xmlns:asvg="http://schemas.microsoft.com/office/drawing/2016/SVG/main" xmlns="" r:embed="rId5"/>
+                  <asvg:svgBlip xmlns="" xmlns:asvg="http://schemas.microsoft.com/office/drawing/2016/SVG/main" r:embed="rId5"/>
                 </a:ext>
               </a:extLst>
             </a:blip>
@@ -14831,7 +14853,7 @@
             <a:blip r:embed="rId6">
               <a:extLst>
                 <a:ext uri="{96DAC541-7B7A-43D3-8B79-37D633B846F1}">
-                  <asvg:svgBlip xmlns:asvg="http://schemas.microsoft.com/office/drawing/2016/SVG/main" xmlns="" r:embed="rId7"/>
+                  <asvg:svgBlip xmlns="" xmlns:asvg="http://schemas.microsoft.com/office/drawing/2016/SVG/main" r:embed="rId7"/>
                 </a:ext>
               </a:extLst>
             </a:blip>
@@ -15107,8 +15129,8 @@
         </p:nvSpPr>
         <p:spPr bwMode="auto">
           <a:xfrm>
-            <a:off x="9684029" y="2576908"/>
-            <a:ext cx="7575271" cy="4154984"/>
+            <a:off x="9760229" y="3071397"/>
+            <a:ext cx="7575271" cy="4524315"/>
           </a:xfrm>
           <a:prstGeom prst="rect">
             <a:avLst/>
@@ -15156,21 +15178,15 @@
           </a:bodyPr>
           <a:lstStyle/>
           <a:p>
-            <a:pPr marL="342900" marR="0" lvl="0" indent="-342900" algn="just" defTabSz="914400" rtl="0" eaLnBrk="0" fontAlgn="base" latinLnBrk="0" hangingPunct="0">
-              <a:lnSpc>
-                <a:spcPct val="100000"/>
-              </a:lnSpc>
+            <a:pPr marL="342900" indent="-342900" algn="just" eaLnBrk="0" fontAlgn="base" hangingPunct="0">
               <a:spcBef>
                 <a:spcPct val="0"/>
               </a:spcBef>
               <a:spcAft>
                 <a:spcPct val="0"/>
               </a:spcAft>
-              <a:buClrTx/>
-              <a:buSzTx/>
               <a:buFont typeface="Arial" panose="020B0604020202020204" pitchFamily="34" charset="0"/>
               <a:buChar char="•"/>
-              <a:tabLst/>
             </a:pPr>
             <a:r>
               <a:rPr kumimoji="0" lang="en-US" sz="2400" b="1" i="0" u="none" strike="noStrike" cap="none" normalizeH="0" baseline="0" dirty="0" smtClean="0">
@@ -15194,7 +15210,7 @@
                 <a:latin typeface="Times New Roman" panose="02020603050405020304" pitchFamily="18" charset="0"/>
                 <a:cs typeface="Times New Roman" panose="02020603050405020304" pitchFamily="18" charset="0"/>
               </a:rPr>
-              <a:t> </a:t>
+              <a:t> Interactive Customization (MDPI Paper, 2022</a:t>
             </a:r>
             <a:r>
               <a:rPr lang="en-US" sz="2400" dirty="0" smtClean="0">
@@ -15204,39 +15220,30 @@
                 <a:latin typeface="Times New Roman" panose="02020603050405020304" pitchFamily="18" charset="0"/>
                 <a:cs typeface="Times New Roman" panose="02020603050405020304" pitchFamily="18" charset="0"/>
               </a:rPr>
-              <a:t>O</a:t>
-            </a:r>
-            <a:r>
-              <a:rPr kumimoji="0" lang="en-US" sz="2400" b="0" i="0" u="none" strike="noStrike" cap="none" normalizeH="0" baseline="0" dirty="0" smtClean="0">
-                <a:ln>
-                  <a:noFill/>
-                </a:ln>
-                <a:solidFill>
-                  <a:schemeClr val="bg1"/>
-                </a:solidFill>
-                <a:effectLst/>
-                <a:latin typeface="Times New Roman" panose="02020603050405020304" pitchFamily="18" charset="0"/>
-                <a:cs typeface="Times New Roman" panose="02020603050405020304" pitchFamily="18" charset="0"/>
-              </a:rPr>
-              <a:t>nline stores display static product images (Ahmed &amp; Tariq, 2022). </a:t>
-            </a:r>
-          </a:p>
-          <a:p>
-            <a:pPr marL="342900" marR="0" lvl="0" indent="-342900" algn="just" defTabSz="914400" rtl="0" eaLnBrk="0" fontAlgn="base" latinLnBrk="0" hangingPunct="0">
-              <a:lnSpc>
-                <a:spcPct val="100000"/>
-              </a:lnSpc>
+              <a:t>)</a:t>
+            </a:r>
+            <a:endParaRPr kumimoji="0" lang="en-US" sz="2400" b="1" u="none" strike="noStrike" cap="none" normalizeH="0" baseline="0" dirty="0" smtClean="0">
+              <a:ln>
+                <a:noFill/>
+              </a:ln>
+              <a:solidFill>
+                <a:schemeClr val="bg1"/>
+              </a:solidFill>
+              <a:effectLst/>
+              <a:latin typeface="Times New Roman" panose="02020603050405020304" pitchFamily="18" charset="0"/>
+              <a:cs typeface="Times New Roman" panose="02020603050405020304" pitchFamily="18" charset="0"/>
+            </a:endParaRPr>
+          </a:p>
+          <a:p>
+            <a:pPr marL="342900" indent="-342900" algn="just" eaLnBrk="0" fontAlgn="base" hangingPunct="0">
               <a:spcBef>
                 <a:spcPct val="0"/>
               </a:spcBef>
               <a:spcAft>
                 <a:spcPct val="0"/>
               </a:spcAft>
-              <a:buClrTx/>
-              <a:buSzTx/>
               <a:buFont typeface="Arial" panose="020B0604020202020204" pitchFamily="34" charset="0"/>
               <a:buChar char="•"/>
-              <a:tabLst/>
             </a:pPr>
             <a:r>
               <a:rPr kumimoji="0" lang="en-US" sz="2400" b="1" i="0" u="none" strike="noStrike" cap="none" normalizeH="0" baseline="0" dirty="0" smtClean="0">
@@ -15264,53 +15271,60 @@
                 <a:latin typeface="Times New Roman" panose="02020603050405020304" pitchFamily="18" charset="0"/>
                 <a:cs typeface="Times New Roman" panose="02020603050405020304" pitchFamily="18" charset="0"/>
               </a:rPr>
-              <a:t> E-commerce chatbots are</a:t>
-            </a:r>
-            <a:r>
-              <a:rPr kumimoji="0" lang="en-US" sz="2400" b="0" i="0" u="none" strike="noStrike" cap="none" normalizeH="0" dirty="0" smtClean="0">
-                <a:ln>
-                  <a:noFill/>
-                </a:ln>
+              <a:t> </a:t>
+            </a:r>
+            <a:r>
+              <a:rPr lang="fr-FR" sz="2400" dirty="0" smtClean="0">
                 <a:solidFill>
                   <a:schemeClr val="bg1"/>
                 </a:solidFill>
-                <a:effectLst/>
-                <a:latin typeface="Times New Roman" panose="02020603050405020304" pitchFamily="18" charset="0"/>
-                <a:cs typeface="Times New Roman" panose="02020603050405020304" pitchFamily="18" charset="0"/>
-              </a:rPr>
-              <a:t> predefined</a:t>
-            </a:r>
-            <a:r>
-              <a:rPr kumimoji="0" lang="en-US" sz="2400" b="0" i="0" u="none" strike="noStrike" cap="none" normalizeH="0" baseline="0" dirty="0" smtClean="0">
-                <a:ln>
-                  <a:noFill/>
-                </a:ln>
+                <a:latin typeface="Times New Roman" panose="02020603050405020304" pitchFamily="18" charset="0"/>
+                <a:cs typeface="Times New Roman" panose="02020603050405020304" pitchFamily="18" charset="0"/>
+              </a:rPr>
+              <a:t>Intelligent </a:t>
+            </a:r>
+            <a:r>
+              <a:rPr lang="fr-FR" sz="2400" dirty="0">
                 <a:solidFill>
                   <a:schemeClr val="bg1"/>
                 </a:solidFill>
-                <a:effectLst/>
-                <a:latin typeface="Times New Roman" panose="02020603050405020304" pitchFamily="18" charset="0"/>
-                <a:cs typeface="Times New Roman" panose="02020603050405020304" pitchFamily="18" charset="0"/>
-              </a:rPr>
-              <a:t> (Khan &amp; Raza, 2023). </a:t>
-            </a:r>
-          </a:p>
-          <a:p>
-            <a:pPr marL="342900" marR="0" lvl="0" indent="-342900" algn="just" defTabSz="914400" rtl="0" eaLnBrk="0" fontAlgn="base" latinLnBrk="0" hangingPunct="0">
-              <a:lnSpc>
-                <a:spcPct val="100000"/>
-              </a:lnSpc>
+                <a:latin typeface="Times New Roman" panose="02020603050405020304" pitchFamily="18" charset="0"/>
+                <a:cs typeface="Times New Roman" panose="02020603050405020304" pitchFamily="18" charset="0"/>
+              </a:rPr>
+              <a:t>Support vs Scripts (Elsevier, 2023</a:t>
+            </a:r>
+            <a:r>
+              <a:rPr lang="fr-FR" sz="2400" dirty="0" smtClean="0">
+                <a:solidFill>
+                  <a:schemeClr val="bg1"/>
+                </a:solidFill>
+                <a:latin typeface="Times New Roman" panose="02020603050405020304" pitchFamily="18" charset="0"/>
+                <a:cs typeface="Times New Roman" panose="02020603050405020304" pitchFamily="18" charset="0"/>
+              </a:rPr>
+              <a:t>)</a:t>
+            </a:r>
+            <a:endParaRPr kumimoji="0" lang="en-US" sz="2400" b="1" i="0" u="none" strike="noStrike" cap="none" normalizeH="0" baseline="0" dirty="0" smtClean="0">
+              <a:ln>
+                <a:noFill/>
+              </a:ln>
+              <a:solidFill>
+                <a:schemeClr val="bg1"/>
+              </a:solidFill>
+              <a:effectLst/>
+              <a:latin typeface="Times New Roman" panose="02020603050405020304" pitchFamily="18" charset="0"/>
+              <a:cs typeface="Times New Roman" panose="02020603050405020304" pitchFamily="18" charset="0"/>
+            </a:endParaRPr>
+          </a:p>
+          <a:p>
+            <a:pPr marL="342900" lvl="0" indent="-342900" algn="just" eaLnBrk="0" fontAlgn="base" hangingPunct="0">
               <a:spcBef>
                 <a:spcPct val="0"/>
               </a:spcBef>
               <a:spcAft>
                 <a:spcPct val="0"/>
               </a:spcAft>
-              <a:buClrTx/>
-              <a:buSzTx/>
               <a:buFont typeface="Arial" panose="020B0604020202020204" pitchFamily="34" charset="0"/>
               <a:buChar char="•"/>
-              <a:tabLst/>
             </a:pPr>
             <a:r>
               <a:rPr kumimoji="0" lang="en-US" sz="2400" b="1" i="0" u="none" strike="noStrike" cap="none" normalizeH="0" baseline="0" dirty="0" smtClean="0">
@@ -15338,25 +15352,40 @@
                 <a:latin typeface="Times New Roman" panose="02020603050405020304" pitchFamily="18" charset="0"/>
                 <a:cs typeface="Times New Roman" panose="02020603050405020304" pitchFamily="18" charset="0"/>
               </a:rPr>
-              <a:t> Existing platforms require administrators to manually create product descriptions (Fatima et al., 2021). </a:t>
-            </a:r>
-          </a:p>
-          <a:p>
-            <a:pPr marL="342900" marR="0" lvl="0" indent="-342900" algn="just" defTabSz="914400" rtl="0" eaLnBrk="0" fontAlgn="base" latinLnBrk="0" hangingPunct="0">
-              <a:lnSpc>
-                <a:spcPct val="100000"/>
-              </a:lnSpc>
+              <a:t> Existing platforms require administrators to manually </a:t>
+            </a:r>
+            <a:r>
+              <a:rPr lang="en-US" sz="2400" dirty="0" smtClean="0">
+                <a:solidFill>
+                  <a:schemeClr val="bg1"/>
+                </a:solidFill>
+                <a:latin typeface="Times New Roman" panose="02020603050405020304" pitchFamily="18" charset="0"/>
+                <a:cs typeface="Times New Roman" panose="02020603050405020304" pitchFamily="18" charset="0"/>
+              </a:rPr>
+              <a:t>manage orders (Sandra Santasärkkä Optimizing and Automation)</a:t>
+            </a:r>
+            <a:endParaRPr kumimoji="0" lang="en-US" sz="2400" b="0" i="0" u="none" strike="noStrike" cap="none" normalizeH="0" baseline="0" dirty="0" smtClean="0">
+              <a:ln>
+                <a:noFill/>
+              </a:ln>
+              <a:solidFill>
+                <a:schemeClr val="bg1"/>
+              </a:solidFill>
+              <a:effectLst/>
+              <a:latin typeface="Times New Roman" panose="02020603050405020304" pitchFamily="18" charset="0"/>
+              <a:cs typeface="Times New Roman" panose="02020603050405020304" pitchFamily="18" charset="0"/>
+            </a:endParaRPr>
+          </a:p>
+          <a:p>
+            <a:pPr marL="342900" lvl="0" indent="-342900" algn="just" eaLnBrk="0" fontAlgn="base" hangingPunct="0">
               <a:spcBef>
                 <a:spcPct val="0"/>
               </a:spcBef>
               <a:spcAft>
                 <a:spcPct val="0"/>
               </a:spcAft>
-              <a:buClrTx/>
-              <a:buSzTx/>
               <a:buFont typeface="Arial" panose="020B0604020202020204" pitchFamily="34" charset="0"/>
               <a:buChar char="•"/>
-              <a:tabLst/>
             </a:pPr>
             <a:r>
               <a:rPr kumimoji="0" lang="en-US" sz="2400" b="1" i="0" u="none" strike="noStrike" cap="none" normalizeH="0" baseline="0" dirty="0" smtClean="0">
@@ -15370,50 +15399,49 @@
                 <a:latin typeface="Times New Roman" panose="02020603050405020304" pitchFamily="18" charset="0"/>
                 <a:cs typeface="Times New Roman" panose="02020603050405020304" pitchFamily="18" charset="0"/>
               </a:rPr>
-              <a:t>Lack of an Integrated AI-Powered Local E-Commerce Platform:</a:t>
-            </a:r>
-            <a:r>
-              <a:rPr kumimoji="0" lang="en-US" sz="2400" b="0" i="0" u="none" strike="noStrike" cap="none" normalizeH="0" baseline="0" dirty="0" smtClean="0">
-                <a:ln>
-                  <a:noFill/>
-                </a:ln>
+              <a:t> </a:t>
+            </a:r>
+            <a:r>
+              <a:rPr lang="en-US" sz="2400" b="1" dirty="0">
                 <a:solidFill>
                   <a:schemeClr val="bg1"/>
                 </a:solidFill>
-                <a:effectLst/>
-                <a:latin typeface="Times New Roman" panose="02020603050405020304" pitchFamily="18" charset="0"/>
-                <a:cs typeface="Times New Roman" panose="02020603050405020304" pitchFamily="18" charset="0"/>
-              </a:rPr>
-              <a:t> Current solutions do not combine interactive apparel customization</a:t>
-            </a:r>
-            <a:r>
-              <a:rPr kumimoji="0" lang="en-US" sz="2400" b="0" i="0" u="none" strike="noStrike" cap="none" normalizeH="0" dirty="0" smtClean="0">
-                <a:ln>
-                  <a:noFill/>
-                </a:ln>
+                <a:latin typeface="Times New Roman" panose="02020603050405020304" pitchFamily="18" charset="0"/>
+                <a:cs typeface="Times New Roman" panose="02020603050405020304" pitchFamily="18" charset="0"/>
+              </a:rPr>
+              <a:t>Manual Inventory </a:t>
+            </a:r>
+            <a:r>
+              <a:rPr lang="en-US" sz="2400" b="1" dirty="0" smtClean="0">
                 <a:solidFill>
                   <a:schemeClr val="bg1"/>
                 </a:solidFill>
-                <a:effectLst/>
-                <a:latin typeface="Times New Roman" panose="02020603050405020304" pitchFamily="18" charset="0"/>
-                <a:cs typeface="Times New Roman" panose="02020603050405020304" pitchFamily="18" charset="0"/>
-              </a:rPr>
-              <a:t> and </a:t>
-            </a:r>
-            <a:r>
-              <a:rPr kumimoji="0" lang="en-US" sz="2400" b="0" i="0" u="none" strike="noStrike" cap="none" normalizeH="0" baseline="0" dirty="0" smtClean="0">
-                <a:ln>
-                  <a:noFill/>
-                </a:ln>
+                <a:latin typeface="Times New Roman" panose="02020603050405020304" pitchFamily="18" charset="0"/>
+                <a:cs typeface="Times New Roman" panose="02020603050405020304" pitchFamily="18" charset="0"/>
+              </a:rPr>
+              <a:t>Management:</a:t>
+            </a:r>
+            <a:r>
+              <a:rPr lang="en-US" sz="2400" dirty="0">
                 <a:solidFill>
                   <a:schemeClr val="bg1"/>
                 </a:solidFill>
-                <a:effectLst/>
-                <a:latin typeface="Times New Roman" panose="02020603050405020304" pitchFamily="18" charset="0"/>
-                <a:cs typeface="Times New Roman" panose="02020603050405020304" pitchFamily="18" charset="0"/>
-              </a:rPr>
-              <a:t>intelligent customer support (Hussain &amp; Ali, 2023). </a:t>
-            </a:r>
+                <a:latin typeface="Times New Roman" panose="02020603050405020304" pitchFamily="18" charset="0"/>
+                <a:cs typeface="Times New Roman" panose="02020603050405020304" pitchFamily="18" charset="0"/>
+              </a:rPr>
+              <a:t> Current e-commerce systems struggle to track stock levels accurately without automation, leading to frequent out-of-stock situations due to a lack of AI-driven low stock alerts (Tang et al., 2023).</a:t>
+            </a:r>
+            <a:endParaRPr kumimoji="0" lang="en-US" sz="2400" b="0" i="0" u="none" strike="noStrike" cap="none" normalizeH="0" baseline="0" dirty="0" smtClean="0">
+              <a:ln>
+                <a:noFill/>
+              </a:ln>
+              <a:solidFill>
+                <a:schemeClr val="bg1"/>
+              </a:solidFill>
+              <a:effectLst/>
+              <a:latin typeface="Times New Roman" panose="02020603050405020304" pitchFamily="18" charset="0"/>
+              <a:cs typeface="Times New Roman" panose="02020603050405020304" pitchFamily="18" charset="0"/>
+            </a:endParaRPr>
           </a:p>
         </p:txBody>
       </p:sp>
@@ -15503,7 +15531,7 @@
             <a:blip r:embed="rId2">
               <a:extLst>
                 <a:ext uri="{96DAC541-7B7A-43D3-8B79-37D633B846F1}">
-                  <asvg:svgBlip xmlns:asvg="http://schemas.microsoft.com/office/drawing/2016/SVG/main" xmlns="" r:embed="rId3"/>
+                  <asvg:svgBlip xmlns="" xmlns:asvg="http://schemas.microsoft.com/office/drawing/2016/SVG/main" r:embed="rId3"/>
                 </a:ext>
               </a:extLst>
             </a:blip>
@@ -15555,7 +15583,7 @@
             <a:blip r:embed="rId2">
               <a:extLst>
                 <a:ext uri="{96DAC541-7B7A-43D3-8B79-37D633B846F1}">
-                  <asvg:svgBlip xmlns:asvg="http://schemas.microsoft.com/office/drawing/2016/SVG/main" xmlns="" r:embed="rId3"/>
+                  <asvg:svgBlip xmlns="" xmlns:asvg="http://schemas.microsoft.com/office/drawing/2016/SVG/main" r:embed="rId3"/>
                 </a:ext>
               </a:extLst>
             </a:blip>
@@ -15809,7 +15837,7 @@
             <a:blip r:embed="rId4">
               <a:extLst>
                 <a:ext uri="{96DAC541-7B7A-43D3-8B79-37D633B846F1}">
-                  <asvg:svgBlip xmlns:asvg="http://schemas.microsoft.com/office/drawing/2016/SVG/main" xmlns="" r:embed="rId5"/>
+                  <asvg:svgBlip xmlns="" xmlns:asvg="http://schemas.microsoft.com/office/drawing/2016/SVG/main" r:embed="rId5"/>
                 </a:ext>
               </a:extLst>
             </a:blip>
@@ -15961,7 +15989,7 @@
             <a:blip r:embed="rId4">
               <a:extLst>
                 <a:ext uri="{96DAC541-7B7A-43D3-8B79-37D633B846F1}">
-                  <asvg:svgBlip xmlns:asvg="http://schemas.microsoft.com/office/drawing/2016/SVG/main" xmlns="" r:embed="rId5"/>
+                  <asvg:svgBlip xmlns="" xmlns:asvg="http://schemas.microsoft.com/office/drawing/2016/SVG/main" r:embed="rId5"/>
                 </a:ext>
               </a:extLst>
             </a:blip>
@@ -16234,7 +16262,7 @@
             <a:blip r:embed="rId6">
               <a:extLst>
                 <a:ext uri="{96DAC541-7B7A-43D3-8B79-37D633B846F1}">
-                  <asvg:svgBlip xmlns:asvg="http://schemas.microsoft.com/office/drawing/2016/SVG/main" xmlns="" r:embed="rId7"/>
+                  <asvg:svgBlip xmlns="" xmlns:asvg="http://schemas.microsoft.com/office/drawing/2016/SVG/main" r:embed="rId7"/>
                 </a:ext>
               </a:extLst>
             </a:blip>
@@ -16444,7 +16472,7 @@
             <a:blip r:embed="rId2">
               <a:extLst>
                 <a:ext uri="{96DAC541-7B7A-43D3-8B79-37D633B846F1}">
-                  <asvg:svgBlip xmlns:asvg="http://schemas.microsoft.com/office/drawing/2016/SVG/main" xmlns="" r:embed="rId3"/>
+                  <asvg:svgBlip xmlns="" xmlns:asvg="http://schemas.microsoft.com/office/drawing/2016/SVG/main" r:embed="rId3"/>
                 </a:ext>
               </a:extLst>
             </a:blip>
@@ -16496,7 +16524,7 @@
             <a:blip r:embed="rId2">
               <a:extLst>
                 <a:ext uri="{96DAC541-7B7A-43D3-8B79-37D633B846F1}">
-                  <asvg:svgBlip xmlns:asvg="http://schemas.microsoft.com/office/drawing/2016/SVG/main" xmlns="" r:embed="rId3"/>
+                  <asvg:svgBlip xmlns="" xmlns:asvg="http://schemas.microsoft.com/office/drawing/2016/SVG/main" r:embed="rId3"/>
                 </a:ext>
               </a:extLst>
             </a:blip>
@@ -16800,7 +16828,7 @@
             <a:blip r:embed="rId4">
               <a:extLst>
                 <a:ext uri="{96DAC541-7B7A-43D3-8B79-37D633B846F1}">
-                  <asvg:svgBlip xmlns:asvg="http://schemas.microsoft.com/office/drawing/2016/SVG/main" xmlns="" r:embed="rId5"/>
+                  <asvg:svgBlip xmlns="" xmlns:asvg="http://schemas.microsoft.com/office/drawing/2016/SVG/main" r:embed="rId5"/>
                 </a:ext>
               </a:extLst>
             </a:blip>
@@ -16837,13 +16865,22 @@
               </a:spcBef>
             </a:pPr>
             <a:r>
+              <a:rPr lang="en-US" sz="2400" b="1" smtClean="0">
+                <a:latin typeface="Times New Roman" panose="02020603050405020304" pitchFamily="18" charset="0"/>
+                <a:ea typeface="Times New Roman"/>
+                <a:cs typeface="Times New Roman" panose="02020603050405020304" pitchFamily="18" charset="0"/>
+                <a:sym typeface="Times New Roman"/>
+              </a:rPr>
+              <a:t>AI Frameworks</a:t>
+            </a:r>
+            <a:r>
               <a:rPr lang="en-US" sz="2400" b="1" dirty="0">
                 <a:latin typeface="Times New Roman" panose="02020603050405020304" pitchFamily="18" charset="0"/>
                 <a:ea typeface="Times New Roman"/>
                 <a:cs typeface="Times New Roman" panose="02020603050405020304" pitchFamily="18" charset="0"/>
                 <a:sym typeface="Times New Roman"/>
               </a:rPr>
-              <a:t>AI/ML Frameworks: </a:t>
+              <a:t>: </a:t>
             </a:r>
             <a:r>
               <a:rPr lang="fr-FR" sz="2400" dirty="0">
@@ -16903,7 +16940,7 @@
             <a:blip r:embed="rId4">
               <a:extLst>
                 <a:ext uri="{96DAC541-7B7A-43D3-8B79-37D633B846F1}">
-                  <asvg:svgBlip xmlns:asvg="http://schemas.microsoft.com/office/drawing/2016/SVG/main" xmlns="" r:embed="rId5"/>
+                  <asvg:svgBlip xmlns="" xmlns:asvg="http://schemas.microsoft.com/office/drawing/2016/SVG/main" r:embed="rId5"/>
                 </a:ext>
               </a:extLst>
             </a:blip>
@@ -17191,7 +17228,7 @@
             <a:blip r:embed="rId6">
               <a:extLst>
                 <a:ext uri="{96DAC541-7B7A-43D3-8B79-37D633B846F1}">
-                  <asvg:svgBlip xmlns:asvg="http://schemas.microsoft.com/office/drawing/2016/SVG/main" xmlns="" r:embed="rId7"/>
+                  <asvg:svgBlip xmlns="" xmlns:asvg="http://schemas.microsoft.com/office/drawing/2016/SVG/main" r:embed="rId7"/>
                 </a:ext>
               </a:extLst>
             </a:blip>
@@ -17375,7 +17412,7 @@
             <a:blip r:embed="rId2">
               <a:extLst>
                 <a:ext uri="{96DAC541-7B7A-43D3-8B79-37D633B846F1}">
-                  <asvg:svgBlip xmlns:asvg="http://schemas.microsoft.com/office/drawing/2016/SVG/main" xmlns="" r:embed="rId3"/>
+                  <asvg:svgBlip xmlns="" xmlns:asvg="http://schemas.microsoft.com/office/drawing/2016/SVG/main" r:embed="rId3"/>
                 </a:ext>
               </a:extLst>
             </a:blip>
@@ -17427,7 +17464,7 @@
             <a:blip r:embed="rId2">
               <a:extLst>
                 <a:ext uri="{96DAC541-7B7A-43D3-8B79-37D633B846F1}">
-                  <asvg:svgBlip xmlns:asvg="http://schemas.microsoft.com/office/drawing/2016/SVG/main" xmlns="" r:embed="rId3"/>
+                  <asvg:svgBlip xmlns="" xmlns:asvg="http://schemas.microsoft.com/office/drawing/2016/SVG/main" r:embed="rId3"/>
                 </a:ext>
               </a:extLst>
             </a:blip>
@@ -17848,7 +17885,7 @@
             <a:blip r:embed="rId2">
               <a:extLst>
                 <a:ext uri="{96DAC541-7B7A-43D3-8B79-37D633B846F1}">
-                  <asvg:svgBlip xmlns:asvg="http://schemas.microsoft.com/office/drawing/2016/SVG/main" xmlns="" r:embed="rId3"/>
+                  <asvg:svgBlip xmlns="" xmlns:asvg="http://schemas.microsoft.com/office/drawing/2016/SVG/main" r:embed="rId3"/>
                 </a:ext>
               </a:extLst>
             </a:blip>
@@ -17900,7 +17937,7 @@
             <a:blip r:embed="rId2">
               <a:extLst>
                 <a:ext uri="{96DAC541-7B7A-43D3-8B79-37D633B846F1}">
-                  <asvg:svgBlip xmlns:asvg="http://schemas.microsoft.com/office/drawing/2016/SVG/main" xmlns="" r:embed="rId3"/>
+                  <asvg:svgBlip xmlns="" xmlns:asvg="http://schemas.microsoft.com/office/drawing/2016/SVG/main" r:embed="rId3"/>
                 </a:ext>
               </a:extLst>
             </a:blip>

</xml_diff>